<commit_message>
Corporate-LLM-Präsentation um HessenPC-Zugang ergänzen
</commit_message>
<xml_diff>
--- a/Anforderungen an eine Corporate LLM/Corporate_LLM_HMKB_Praesentation.pptx
+++ b/Anforderungen an eine Corporate LLM/Corporate_LLM_HMKB_Praesentation.pptx
@@ -877,7 +877,7 @@
           <a:lstStyle/>
           <a:p>
             <a:r>
-              <a:t>Abschluss mit einer konkreten Entscheidungsfrage, nicht mit einem Ausblick. Das Referat soll heute nicht Phase 2 beschließen — es soll entscheiden, ob Phase 1 beginnen darf.</a:t>
+              <a:t>Abschluss mit einer konkreten Klärungs- und Entscheidungsfolge. Das Referat soll Phase 2 heute nicht beschließen. Vor einer Entscheidung über Phase 1 muss der Zugriff vom HessenPC auf die externe Webanwendung bestätigt sein.</a:t>
             </a:r>
           </a:p>
         </p:txBody>
@@ -1017,7 +1017,7 @@
           <a:lstStyle/>
           <a:p>
             <a:r>
-              <a:t>Wichtig: nicht mit Technik einsteigen. Der Schmerz ist bekannt — händische Testfälle und Doku. Die Frage ans Referat lautet später: wollen wir Phase 1 starten, ohne auf die HZD zu warten?</a:t>
+              <a:t>Wichtig: nicht mit Technik einsteigen. Der Schmerz ist bekannt — händische Testfälle und Doku. Für den Pilot sind zwei Fragen zu trennen: Er braucht keine Live-Anbindung an ADO oder SharePoint. Der Zugriff vom HessenPC auf eine extern betriebene Webanwendung muss aber vorab technisch und organisatorisch bestätigt werden.</a:t>
             </a:r>
           </a:p>
         </p:txBody>
@@ -1087,7 +1087,7 @@
           <a:lstStyle/>
           <a:p>
             <a:r>
-              <a:t>RAG = die KI schlägt in den eigenen Dokumenten nach, bevor sie antwortet. Dadurch erfindet sie deutlich weniger. Alle vier Bausteine sind Open Source — es fallen keine Lizenzkosten an, nur Hardware und Arbeit.</a:t>
+              <a:t>Das Open-Weight-Modell ist das sprachliche Gehirn und läuft auf dem Server. Open WebUI ist die zentrale Weboberfläche. Berechtigte pflegen dort freigegebene Dokumente in die Wissensbasis ein; die Dokumente werden serverseitig für die Suche aufbereitet. Nutzende melden sich an und wählen einen vorkonfigurierten Assistenten. Keine Installation am HessenPC ist nötig. Entscheidend ist jedoch, ob die externe HTTPS-Adresse erreichbar und der Dokumentenupload zulässig ist.</a:t>
             </a:r>
           </a:p>
         </p:txBody>
@@ -1367,7 +1367,7 @@
           <a:lstStyle/>
           <a:p>
             <a:r>
-              <a:t>Kernbotschaft der Präsentation. Phase 1 ist kein Kompromiss und keine Notlösung, sondern ein vollwertiger erster Schritt. Phase 2 ist ein Ziel, kein Versprechen — sie hängt an einer Entscheidung, die weder das Referat noch wir allein treffen können.</a:t>
+              <a:t>Kernbotschaft der Präsentation. Phase 1 braucht keine Live-Verbindung zu ADO oder SharePoint. Sie ist aber nur am HessenPC nutzbar, wenn die externe, authentifizierte HTTPS-Webadresse erreichbar ist und der Datei-Upload erlaubt wird. Phase 2 bleibt ein Ziel und erfordert die HZD.</a:t>
             </a:r>
           </a:p>
         </p:txBody>
@@ -7483,7 +7483,7 @@
               </a:spcAft>
             </a:pPr>
             <a:r>
-              <a:rPr sz="1400" b="1">
+              <a:rPr sz="1200" b="1">
                 <a:solidFill>
                   <a:srgbClr val="1F3B63"/>
                 </a:solidFill>
@@ -7498,7 +7498,7 @@
               </a:spcAft>
             </a:pPr>
             <a:r>
-              <a:rPr sz="1200" b="0">
+              <a:rPr sz="1000" b="0">
                 <a:solidFill>
                   <a:srgbClr val="595959"/>
                 </a:solidFill>
@@ -7513,7 +7513,7 @@
               </a:spcAft>
             </a:pPr>
             <a:r>
-              <a:rPr sz="1200" b="0">
+              <a:rPr sz="1000" b="0">
                 <a:solidFill>
                   <a:srgbClr val="595959"/>
                 </a:solidFill>
@@ -7528,7 +7528,7 @@
               </a:spcAft>
             </a:pPr>
             <a:r>
-              <a:rPr sz="1200" b="0">
+              <a:rPr sz="1000" b="0">
                 <a:solidFill>
                   <a:srgbClr val="595959"/>
                 </a:solidFill>
@@ -7543,12 +7543,12 @@
               </a:spcAft>
             </a:pPr>
             <a:r>
-              <a:rPr sz="1200" b="0">
+              <a:rPr sz="1000" b="0">
                 <a:solidFill>
                   <a:srgbClr val="595959"/>
                 </a:solidFill>
               </a:rPr>
-              <a:t>Besteht eine Ausschreibungspflicht?</a:t>
+              <a:t>Dürfen HessenPCs eine externe, authentifizierte HTTPS-Webanwendung aufrufen?</a:t>
             </a:r>
           </a:p>
           <a:p>
@@ -7558,12 +7558,12 @@
               </a:spcAft>
             </a:pPr>
             <a:r>
-              <a:rPr sz="1200" b="0">
+              <a:rPr sz="1000" b="0">
                 <a:solidFill>
                   <a:srgbClr val="595959"/>
                 </a:solidFill>
               </a:rPr>
-              <a:t>Gibt es bereits eine KI-Nutzungsrichtlinie im Haus?</a:t>
+              <a:t>Dürfen freigegebene Dokumente vom HessenPC dorthin hochgeladen werden?</a:t>
             </a:r>
           </a:p>
           <a:p>
@@ -7573,12 +7573,12 @@
               </a:spcAft>
             </a:pPr>
             <a:r>
-              <a:rPr sz="1200" b="0">
+              <a:rPr sz="1000" b="0">
                 <a:solidFill>
                   <a:srgbClr val="595959"/>
                 </a:solidFill>
               </a:rPr>
-              <a:t>Wurde das Vorhaben mit dem Datenschutzbeauftragten besprochen?</a:t>
+              <a:t>Besteht eine Ausschreibungspflicht?</a:t>
             </a:r>
           </a:p>
           <a:p>
@@ -7588,7 +7588,37 @@
               </a:spcAft>
             </a:pPr>
             <a:r>
-              <a:rPr sz="1200" b="0">
+              <a:rPr sz="1000" b="0">
+                <a:solidFill>
+                  <a:srgbClr val="595959"/>
+                </a:solidFill>
+              </a:rPr>
+              <a:t>Gibt es bereits eine KI-Nutzungsrichtlinie im Haus?</a:t>
+            </a:r>
+          </a:p>
+          <a:p>
+            <a:pPr lvl="1">
+              <a:spcAft>
+                <a:spcPts val="600"/>
+              </a:spcAft>
+            </a:pPr>
+            <a:r>
+              <a:rPr sz="1000" b="0">
+                <a:solidFill>
+                  <a:srgbClr val="595959"/>
+                </a:solidFill>
+              </a:rPr>
+              <a:t>Wurde das Vorhaben mit dem Datenschutzbeauftragten besprochen?</a:t>
+            </a:r>
+          </a:p>
+          <a:p>
+            <a:pPr lvl="1">
+              <a:spcAft>
+                <a:spcPts val="600"/>
+              </a:spcAft>
+            </a:pPr>
+            <a:r>
+              <a:rPr sz="1000" b="0">
                 <a:solidFill>
                   <a:srgbClr val="595959"/>
                 </a:solidFill>
@@ -7610,7 +7640,7 @@
               </a:spcAft>
             </a:pPr>
             <a:r>
-              <a:rPr sz="1400" b="1">
+              <a:rPr sz="1200" b="1">
                 <a:solidFill>
                   <a:srgbClr val="1F3B63"/>
                 </a:solidFill>
@@ -7625,12 +7655,12 @@
               </a:spcAft>
             </a:pPr>
             <a:r>
-              <a:rPr sz="1200" b="0">
+              <a:rPr sz="1000" b="0">
                 <a:solidFill>
                   <a:srgbClr val="595959"/>
                 </a:solidFill>
               </a:rPr>
-              <a:t>Entscheidung des Referats: Phase 1 starten, ohne auf die HZD zu warten</a:t>
+              <a:t>HessenPC-Zugang kurzfristig mit der zuständigen IT verbindlich klären</a:t>
             </a:r>
           </a:p>
           <a:p>
@@ -7640,12 +7670,12 @@
               </a:spcAft>
             </a:pPr>
             <a:r>
-              <a:rPr sz="1200" b="0">
+              <a:rPr sz="1000" b="0">
                 <a:solidFill>
                   <a:srgbClr val="595959"/>
                 </a:solidFill>
               </a:rPr>
-              <a:t>Parallel klären, ob Phase 2 mittelfristig realistisch ist</a:t>
+              <a:t>Danach Entscheidung des Referats über den Start von Phase 1</a:t>
             </a:r>
           </a:p>
           <a:p>
@@ -7655,7 +7685,22 @@
               </a:spcAft>
             </a:pPr>
             <a:r>
-              <a:rPr sz="1200" b="0">
+              <a:rPr sz="1000" b="0">
+                <a:solidFill>
+                  <a:srgbClr val="595959"/>
+                </a:solidFill>
+              </a:rPr>
+              <a:t>Parallel klären, ob Phase 2 mittelfristig realistisch ist</a:t>
+            </a:r>
+          </a:p>
+          <a:p>
+            <a:pPr lvl="1">
+              <a:spcAft>
+                <a:spcPts val="600"/>
+              </a:spcAft>
+            </a:pPr>
+            <a:r>
+              <a:rPr sz="1000" b="0">
                 <a:solidFill>
                   <a:srgbClr val="595959"/>
                 </a:solidFill>
@@ -7699,12 +7744,12 @@
           <a:lstStyle/>
           <a:p>
             <a:r>
-              <a:t>Wir können sofort anfangen — ohne die HZD, innerhalb des Budgets, mit rund 80 % des Nutzens.</a:t>
-            </a:r>
-          </a:p>
-          <a:p>
-            <a:r>
-              <a:t>Alles Weitere ist eine politische Entscheidung, keine technische.</a:t>
+              <a:t>Der Pilot braucht keine Live-Anbindung an ADO oder SharePoint und bleibt im Budget.</a:t>
+            </a:r>
+          </a:p>
+          <a:p>
+            <a:r>
+              <a:t>Vor dem Start muss nur noch verbindlich geklärt werden, wie der HessenPC die KI-Webanwendung erreicht.</a:t>
             </a:r>
           </a:p>
         </p:txBody>
@@ -7944,7 +7989,7 @@
                   <a:srgbClr val="595959"/>
                 </a:solidFill>
               </a:rPr>
-              <a:t>Es gibt einen Weg, der sofort funktioniert — ganz ohne die HZD</a:t>
+              <a:t>Ein Pilot ist ohne Live-Anbindung an ADO und SharePoint möglich</a:t>
             </a:r>
           </a:p>
           <a:p>
@@ -7959,7 +8004,22 @@
                   <a:srgbClr val="595959"/>
                 </a:solidFill>
               </a:rPr>
-              <a:t>Und einen Vollausbau, der ohne die HZD nicht geht</a:t>
+              <a:t>Vorher muss geklärt werden, ob HessenPCs die externe KI-Webadresse erreichen dürfen</a:t>
+            </a:r>
+          </a:p>
+          <a:p>
+            <a:pPr lvl="1">
+              <a:spcAft>
+                <a:spcPts val="600"/>
+              </a:spcAft>
+            </a:pPr>
+            <a:r>
+              <a:rPr sz="1300" b="0">
+                <a:solidFill>
+                  <a:srgbClr val="595959"/>
+                </a:solidFill>
+              </a:rPr>
+              <a:t>Der Vollausbau im Hessennetz ist nur gemeinsam mit der HZD möglich</a:t>
             </a:r>
           </a:p>
         </p:txBody>
@@ -7998,7 +8058,7 @@
           <a:lstStyle/>
           <a:p>
             <a:r>
-              <a:t>Was eine „Keller-KI“ ist</a:t>
+              <a:t>So erreicht die Keller-KI den HessenPC</a:t>
             </a:r>
           </a:p>
         </p:txBody>
@@ -8011,8 +8071,8 @@
         </p:nvSpPr>
         <p:spPr>
           <a:xfrm>
-            <a:off x="457200" y="1234440"/>
-            <a:ext cx="1965960" cy="1417320"/>
+            <a:off x="411480" y="1143000"/>
+            <a:ext cx="1828800" cy="1188720"/>
           </a:xfrm>
           <a:prstGeom prst="roundRect">
             <a:avLst/>
@@ -8047,12 +8107,12 @@
           <a:p>
             <a:pPr algn="l"/>
             <a:r>
-              <a:rPr sz="1300" b="1">
+              <a:rPr sz="1400" b="1">
                 <a:solidFill>
                   <a:srgbClr val="1F3B63"/>
                 </a:solidFill>
               </a:rPr>
-              <a:t>Das Modell</a:t>
+              <a:t>1  HessenPC</a:t>
             </a:r>
           </a:p>
           <a:p>
@@ -8067,7 +8127,7 @@
                   <a:srgbClr val="595959"/>
                 </a:solidFill>
               </a:rPr>
-              <a:t>Die Sprach-KI selbst.</a:t>
+              <a:t>Vorhandener Browser</a:t>
             </a:r>
           </a:p>
           <a:p>
@@ -8082,7 +8142,61 @@
                   <a:srgbClr val="595959"/>
                 </a:solidFill>
               </a:rPr>
-              <a:t>Läuft lokal auf eigener</a:t>
+              <a:t>Keine lokale Installation</a:t>
+            </a:r>
+          </a:p>
+        </p:txBody>
+      </p:sp>
+      <p:sp>
+        <p:nvSpPr>
+          <p:cNvPr id="4" name="Rounded Rectangle 3"/>
+          <p:cNvSpPr/>
+          <p:nvPr/>
+        </p:nvSpPr>
+        <p:spPr>
+          <a:xfrm>
+            <a:off x="2514600" y="1143000"/>
+            <a:ext cx="2148840" cy="1188720"/>
+          </a:xfrm>
+          <a:prstGeom prst="roundRect">
+            <a:avLst/>
+          </a:prstGeom>
+          <a:solidFill>
+            <a:srgbClr val="FFFFFF"/>
+          </a:solidFill>
+          <a:ln w="19050">
+            <a:solidFill>
+              <a:srgbClr val="E1001A"/>
+            </a:solidFill>
+          </a:ln>
+          <a:effectLst/>
+        </p:spPr>
+        <p:style>
+          <a:lnRef idx="1">
+            <a:schemeClr val="accent1"/>
+          </a:lnRef>
+          <a:fillRef idx="3">
+            <a:schemeClr val="accent1"/>
+          </a:fillRef>
+          <a:effectRef idx="2">
+            <a:schemeClr val="accent1"/>
+          </a:effectRef>
+          <a:fontRef idx="minor">
+            <a:schemeClr val="lt1"/>
+          </a:fontRef>
+        </p:style>
+        <p:txBody>
+          <a:bodyPr rtlCol="0" anchor="ctr" wrap="square" lIns="146304" rIns="146304" tIns="109728"/>
+          <a:lstStyle/>
+          <a:p>
+            <a:pPr algn="l"/>
+            <a:r>
+              <a:rPr sz="1400" b="1">
+                <a:solidFill>
+                  <a:srgbClr val="E1001A"/>
+                </a:solidFill>
+              </a:rPr>
+              <a:t>2  Sicherer Netzweg</a:t>
             </a:r>
           </a:p>
           <a:p>
@@ -8097,21 +8211,120 @@
                   <a:srgbClr val="595959"/>
                 </a:solidFill>
               </a:rPr>
-              <a:t>Hardware — offline.</a:t>
+              <a:t>Freigegebene HTTPS-Adresse</a:t>
+            </a:r>
+          </a:p>
+          <a:p>
+            <a:pPr>
+              <a:spcBef>
+                <a:spcPts val="400"/>
+              </a:spcBef>
+            </a:pPr>
+            <a:r>
+              <a:rPr sz="1100">
+                <a:solidFill>
+                  <a:srgbClr val="595959"/>
+                </a:solidFill>
+              </a:rPr>
+              <a:t>Anmeldung und Berechtigung</a:t>
             </a:r>
           </a:p>
         </p:txBody>
       </p:sp>
       <p:sp>
         <p:nvSpPr>
-          <p:cNvPr id="4" name="Rounded Rectangle 3"/>
+          <p:cNvPr id="5" name="Rounded Rectangle 4"/>
           <p:cNvSpPr/>
           <p:nvPr/>
         </p:nvSpPr>
         <p:spPr>
           <a:xfrm>
-            <a:off x="2587752" y="1234440"/>
-            <a:ext cx="1965960" cy="1417320"/>
+            <a:off x="4937760" y="1143000"/>
+            <a:ext cx="3794760" cy="1188720"/>
+          </a:xfrm>
+          <a:prstGeom prst="roundRect">
+            <a:avLst/>
+          </a:prstGeom>
+          <a:solidFill>
+            <a:srgbClr val="FFFFFF"/>
+          </a:solidFill>
+          <a:ln w="19050">
+            <a:solidFill>
+              <a:srgbClr val="007A33"/>
+            </a:solidFill>
+          </a:ln>
+          <a:effectLst/>
+        </p:spPr>
+        <p:style>
+          <a:lnRef idx="1">
+            <a:schemeClr val="accent1"/>
+          </a:lnRef>
+          <a:fillRef idx="3">
+            <a:schemeClr val="accent1"/>
+          </a:fillRef>
+          <a:effectRef idx="2">
+            <a:schemeClr val="accent1"/>
+          </a:effectRef>
+          <a:fontRef idx="minor">
+            <a:schemeClr val="lt1"/>
+          </a:fontRef>
+        </p:style>
+        <p:txBody>
+          <a:bodyPr rtlCol="0" anchor="ctr" wrap="square" lIns="146304" rIns="146304" tIns="109728"/>
+          <a:lstStyle/>
+          <a:p>
+            <a:pPr algn="l"/>
+            <a:r>
+              <a:rPr sz="1400" b="1">
+                <a:solidFill>
+                  <a:srgbClr val="007A33"/>
+                </a:solidFill>
+              </a:rPr>
+              <a:t>3  KI-Server</a:t>
+            </a:r>
+          </a:p>
+          <a:p>
+            <a:pPr>
+              <a:spcBef>
+                <a:spcPts val="400"/>
+              </a:spcBef>
+            </a:pPr>
+            <a:r>
+              <a:rPr sz="1100">
+                <a:solidFill>
+                  <a:srgbClr val="595959"/>
+                </a:solidFill>
+              </a:rPr>
+              <a:t>Alle Komponenten laufen zentral</a:t>
+            </a:r>
+          </a:p>
+          <a:p>
+            <a:pPr>
+              <a:spcBef>
+                <a:spcPts val="400"/>
+              </a:spcBef>
+            </a:pPr>
+            <a:r>
+              <a:rPr sz="1100">
+                <a:solidFill>
+                  <a:srgbClr val="595959"/>
+                </a:solidFill>
+              </a:rPr>
+              <a:t>Der HessenPC dient nur zur Bedienung</a:t>
+            </a:r>
+          </a:p>
+        </p:txBody>
+      </p:sp>
+      <p:sp>
+        <p:nvSpPr>
+          <p:cNvPr id="6" name="Rounded Rectangle 5"/>
+          <p:cNvSpPr/>
+          <p:nvPr/>
+        </p:nvSpPr>
+        <p:spPr>
+          <a:xfrm>
+            <a:off x="502920" y="2788920"/>
+            <a:ext cx="1828800" cy="960120"/>
           </a:xfrm>
           <a:prstGeom prst="roundRect">
             <a:avLst/>
@@ -8146,12 +8359,12 @@
           <a:p>
             <a:pPr algn="l"/>
             <a:r>
-              <a:rPr sz="1300" b="1">
+              <a:rPr sz="1200" b="1">
                 <a:solidFill>
                   <a:srgbClr val="1F3B63"/>
                 </a:solidFill>
               </a:rPr>
-              <a:t>Die Oberfläche</a:t>
+              <a:t>Oberfläche</a:t>
             </a:r>
           </a:p>
           <a:p>
@@ -8161,56 +8374,26 @@
               </a:spcBef>
             </a:pPr>
             <a:r>
-              <a:rPr sz="1100">
+              <a:rPr sz="1000">
                 <a:solidFill>
                   <a:srgbClr val="595959"/>
                 </a:solidFill>
               </a:rPr>
-              <a:t>Ein Browser-Fenster,</a:t>
-            </a:r>
-          </a:p>
-          <a:p>
-            <a:pPr>
-              <a:spcBef>
-                <a:spcPts val="400"/>
-              </a:spcBef>
-            </a:pPr>
-            <a:r>
-              <a:rPr sz="1100">
-                <a:solidFill>
-                  <a:srgbClr val="595959"/>
-                </a:solidFill>
-              </a:rPr>
-              <a:t>wie man es von</a:t>
-            </a:r>
-          </a:p>
-          <a:p>
-            <a:pPr>
-              <a:spcBef>
-                <a:spcPts val="400"/>
-              </a:spcBef>
-            </a:pPr>
-            <a:r>
-              <a:rPr sz="1100">
-                <a:solidFill>
-                  <a:srgbClr val="595959"/>
-                </a:solidFill>
-              </a:rPr>
-              <a:t>Chatdiensten kennt.</a:t>
+              <a:t>Chat und Dateiupload</a:t>
             </a:r>
           </a:p>
         </p:txBody>
       </p:sp>
       <p:sp>
         <p:nvSpPr>
-          <p:cNvPr id="5" name="Rounded Rectangle 4"/>
+          <p:cNvPr id="7" name="Rounded Rectangle 6"/>
           <p:cNvSpPr/>
           <p:nvPr/>
         </p:nvSpPr>
         <p:spPr>
           <a:xfrm>
-            <a:off x="4718304" y="1234440"/>
-            <a:ext cx="1965960" cy="1417320"/>
+            <a:off x="2606040" y="2788920"/>
+            <a:ext cx="1828800" cy="960120"/>
           </a:xfrm>
           <a:prstGeom prst="roundRect">
             <a:avLst/>
@@ -8245,16 +8428,12 @@
           <a:p>
             <a:pPr algn="l"/>
             <a:r>
-              <a:rPr sz="1300" b="1">
+              <a:rPr sz="1200" b="1">
                 <a:solidFill>
                   <a:srgbClr val="007A33"/>
                 </a:solidFill>
               </a:rPr>
-              <a:t>Die Wissens-</a:t>
-            </a:r>
-            <a:br/>
-            <a:r>
-              <a:t>datenbank</a:t>
+              <a:t>Agenten</a:t>
             </a:r>
           </a:p>
           <a:p>
@@ -8264,56 +8443,26 @@
               </a:spcBef>
             </a:pPr>
             <a:r>
-              <a:rPr sz="1100">
+              <a:rPr sz="1000">
                 <a:solidFill>
                   <a:srgbClr val="595959"/>
                 </a:solidFill>
               </a:rPr>
-              <a:t>Eigene Dokumente,</a:t>
-            </a:r>
-          </a:p>
-          <a:p>
-            <a:pPr>
-              <a:spcBef>
-                <a:spcPts val="400"/>
-              </a:spcBef>
-            </a:pPr>
-            <a:r>
-              <a:rPr sz="1100">
-                <a:solidFill>
-                  <a:srgbClr val="595959"/>
-                </a:solidFill>
-              </a:rPr>
-              <a:t>durchsuchbar gemacht.</a:t>
-            </a:r>
-          </a:p>
-          <a:p>
-            <a:pPr>
-              <a:spcBef>
-                <a:spcPts val="400"/>
-              </a:spcBef>
-            </a:pPr>
-            <a:r>
-              <a:rPr sz="1100">
-                <a:solidFill>
-                  <a:srgbClr val="595959"/>
-                </a:solidFill>
-              </a:rPr>
-              <a:t>AWAs, Handbücher, Doku.</a:t>
+              <a:t>AWA, Testfall, Wissen</a:t>
             </a:r>
           </a:p>
         </p:txBody>
       </p:sp>
       <p:sp>
         <p:nvSpPr>
-          <p:cNvPr id="6" name="Rounded Rectangle 5"/>
+          <p:cNvPr id="8" name="Rounded Rectangle 7"/>
           <p:cNvSpPr/>
           <p:nvPr/>
         </p:nvSpPr>
         <p:spPr>
           <a:xfrm>
-            <a:off x="6848856" y="1234440"/>
-            <a:ext cx="1965960" cy="1417320"/>
+            <a:off x="4709160" y="2788920"/>
+            <a:ext cx="1828800" cy="960120"/>
           </a:xfrm>
           <a:prstGeom prst="roundRect">
             <a:avLst/>
@@ -8348,12 +8497,12 @@
           <a:p>
             <a:pPr algn="l"/>
             <a:r>
-              <a:rPr sz="1300" b="1">
+              <a:rPr sz="1200" b="1">
                 <a:solidFill>
                   <a:srgbClr val="007A33"/>
                 </a:solidFill>
               </a:rPr>
-              <a:t>Die Agenten</a:t>
+              <a:t>Wissensbasis</a:t>
             </a:r>
           </a:p>
           <a:p>
@@ -8363,12 +8512,66 @@
               </a:spcBef>
             </a:pPr>
             <a:r>
-              <a:rPr sz="1100">
+              <a:rPr sz="1000">
                 <a:solidFill>
                   <a:srgbClr val="595959"/>
                 </a:solidFill>
               </a:rPr>
-              <a:t>Vorkonfigurierte Helfer</a:t>
+              <a:t>Freigegebene Dokumente</a:t>
+            </a:r>
+          </a:p>
+        </p:txBody>
+      </p:sp>
+      <p:sp>
+        <p:nvSpPr>
+          <p:cNvPr id="9" name="Rounded Rectangle 8"/>
+          <p:cNvSpPr/>
+          <p:nvPr/>
+        </p:nvSpPr>
+        <p:spPr>
+          <a:xfrm>
+            <a:off x="6812280" y="2788920"/>
+            <a:ext cx="1828800" cy="960120"/>
+          </a:xfrm>
+          <a:prstGeom prst="roundRect">
+            <a:avLst/>
+          </a:prstGeom>
+          <a:solidFill>
+            <a:srgbClr val="FFFFFF"/>
+          </a:solidFill>
+          <a:ln w="19050">
+            <a:solidFill>
+              <a:srgbClr val="1F3B63"/>
+            </a:solidFill>
+          </a:ln>
+          <a:effectLst/>
+        </p:spPr>
+        <p:style>
+          <a:lnRef idx="1">
+            <a:schemeClr val="accent1"/>
+          </a:lnRef>
+          <a:fillRef idx="3">
+            <a:schemeClr val="accent1"/>
+          </a:fillRef>
+          <a:effectRef idx="2">
+            <a:schemeClr val="accent1"/>
+          </a:effectRef>
+          <a:fontRef idx="minor">
+            <a:schemeClr val="lt1"/>
+          </a:fontRef>
+        </p:style>
+        <p:txBody>
+          <a:bodyPr rtlCol="0" anchor="ctr" wrap="square" lIns="146304" rIns="146304" tIns="109728"/>
+          <a:lstStyle/>
+          <a:p>
+            <a:pPr algn="l"/>
+            <a:r>
+              <a:rPr sz="1200" b="1">
+                <a:solidFill>
+                  <a:srgbClr val="1F3B63"/>
+                </a:solidFill>
+              </a:rPr>
+              <a:t>Open-Weight-Modell</a:t>
             </a:r>
           </a:p>
           <a:p>
@@ -8378,413 +8581,50 @@
               </a:spcBef>
             </a:pPr>
             <a:r>
-              <a:rPr sz="1100">
+              <a:rPr sz="1000">
                 <a:solidFill>
                   <a:srgbClr val="595959"/>
                 </a:solidFill>
               </a:rPr>
-              <a:t>für wiederkehrende</a:t>
-            </a:r>
-          </a:p>
-          <a:p>
-            <a:pPr>
-              <a:spcBef>
-                <a:spcPts val="400"/>
-              </a:spcBef>
-            </a:pPr>
-            <a:r>
-              <a:rPr sz="1100">
-                <a:solidFill>
-                  <a:srgbClr val="595959"/>
-                </a:solidFill>
-              </a:rPr>
-              <a:t>Aufgaben.</a:t>
+              <a:t>Das eigentliche „Gehirn“</a:t>
             </a:r>
           </a:p>
         </p:txBody>
       </p:sp>
-      <p:graphicFrame>
-        <p:nvGraphicFramePr>
-          <p:cNvPr id="7" name="Table 6"/>
-          <p:cNvGraphicFramePr>
-            <a:graphicFrameLocks noGrp="1"/>
-          </p:cNvGraphicFramePr>
+      <p:sp>
+        <p:nvSpPr>
+          <p:cNvPr id="10" name="TextBox 9"/>
+          <p:cNvSpPr txBox="1"/>
           <p:nvPr/>
-        </p:nvGraphicFramePr>
-        <p:xfrm>
-          <a:off x="457200" y="2880360"/>
-          <a:ext cx="8229600" cy="1737360"/>
-        </p:xfrm>
-        <a:graphic>
-          <a:graphicData uri="http://schemas.openxmlformats.org/drawingml/2006/table">
-            <a:tbl>
-              <a:tblPr firstRow="1" bandRow="1">
-                <a:tableStyleId>{5C22544A-7EE6-4342-B048-85BDC9FD1C3A}</a:tableStyleId>
-              </a:tblPr>
-              <a:tblGrid>
-                <a:gridCol w="2377440"/>
-                <a:gridCol w="3291840"/>
-                <a:gridCol w="2560320"/>
-              </a:tblGrid>
-              <a:tr h="347472">
-                <a:tc>
-                  <a:txBody>
-                    <a:bodyPr/>
-                    <a:lstStyle/>
-                    <a:p>
-                      <a:pPr>
-                        <a:defRPr sz="1200" b="1">
-                          <a:solidFill>
-                            <a:srgbClr val="FFFFFF"/>
-                          </a:solidFill>
-                        </a:defRPr>
-                      </a:pPr>
-                      <a:r>
-                        <a:t>Baustein</a:t>
-                      </a:r>
-                    </a:p>
-                  </a:txBody>
-                  <a:tcPr anchor="ctr" marL="73152" marR="73152" marT="27432" marB="27432">
-                    <a:solidFill>
-                      <a:srgbClr val="1F3B63"/>
-                    </a:solidFill>
-                  </a:tcPr>
-                </a:tc>
-                <a:tc>
-                  <a:txBody>
-                    <a:bodyPr/>
-                    <a:lstStyle/>
-                    <a:p>
-                      <a:pPr>
-                        <a:defRPr sz="1200" b="1">
-                          <a:solidFill>
-                            <a:srgbClr val="FFFFFF"/>
-                          </a:solidFill>
-                        </a:defRPr>
-                      </a:pPr>
-                      <a:r>
-                        <a:t>Software</a:t>
-                      </a:r>
-                    </a:p>
-                  </a:txBody>
-                  <a:tcPr anchor="ctr" marL="73152" marR="73152" marT="27432" marB="27432">
-                    <a:solidFill>
-                      <a:srgbClr val="1F3B63"/>
-                    </a:solidFill>
-                  </a:tcPr>
-                </a:tc>
-                <a:tc>
-                  <a:txBody>
-                    <a:bodyPr/>
-                    <a:lstStyle/>
-                    <a:p>
-                      <a:pPr>
-                        <a:defRPr sz="1200" b="1">
-                          <a:solidFill>
-                            <a:srgbClr val="FFFFFF"/>
-                          </a:solidFill>
-                        </a:defRPr>
-                      </a:pPr>
-                      <a:r>
-                        <a:t>Lizenzkosten</a:t>
-                      </a:r>
-                    </a:p>
-                  </a:txBody>
-                  <a:tcPr anchor="ctr" marL="73152" marR="73152" marT="27432" marB="27432">
-                    <a:solidFill>
-                      <a:srgbClr val="1F3B63"/>
-                    </a:solidFill>
-                  </a:tcPr>
-                </a:tc>
-              </a:tr>
-              <a:tr h="347472">
-                <a:tc>
-                  <a:txBody>
-                    <a:bodyPr/>
-                    <a:lstStyle/>
-                    <a:p>
-                      <a:pPr>
-                        <a:defRPr sz="1200">
-                          <a:solidFill>
-                            <a:srgbClr val="595959"/>
-                          </a:solidFill>
-                        </a:defRPr>
-                      </a:pPr>
-                      <a:r>
-                        <a:t>Modellbetrieb</a:t>
-                      </a:r>
-                    </a:p>
-                  </a:txBody>
-                  <a:tcPr anchor="ctr" marL="73152" marR="73152" marT="27432" marB="27432">
-                    <a:solidFill>
-                      <a:srgbClr val="FFFFFF"/>
-                    </a:solidFill>
-                  </a:tcPr>
-                </a:tc>
-                <a:tc>
-                  <a:txBody>
-                    <a:bodyPr/>
-                    <a:lstStyle/>
-                    <a:p>
-                      <a:pPr>
-                        <a:defRPr sz="1200">
-                          <a:solidFill>
-                            <a:srgbClr val="595959"/>
-                          </a:solidFill>
-                        </a:defRPr>
-                      </a:pPr>
-                      <a:r>
-                        <a:t>Ollama</a:t>
-                      </a:r>
-                    </a:p>
-                  </a:txBody>
-                  <a:tcPr anchor="ctr" marL="73152" marR="73152" marT="27432" marB="27432">
-                    <a:solidFill>
-                      <a:srgbClr val="FFFFFF"/>
-                    </a:solidFill>
-                  </a:tcPr>
-                </a:tc>
-                <a:tc>
-                  <a:txBody>
-                    <a:bodyPr/>
-                    <a:lstStyle/>
-                    <a:p>
-                      <a:pPr>
-                        <a:defRPr sz="1200">
-                          <a:solidFill>
-                            <a:srgbClr val="595959"/>
-                          </a:solidFill>
-                        </a:defRPr>
-                      </a:pPr>
-                      <a:r>
-                        <a:t>0 € — Open Source</a:t>
-                      </a:r>
-                    </a:p>
-                  </a:txBody>
-                  <a:tcPr anchor="ctr" marL="73152" marR="73152" marT="27432" marB="27432">
-                    <a:solidFill>
-                      <a:srgbClr val="FFFFFF"/>
-                    </a:solidFill>
-                  </a:tcPr>
-                </a:tc>
-              </a:tr>
-              <a:tr h="347472">
-                <a:tc>
-                  <a:txBody>
-                    <a:bodyPr/>
-                    <a:lstStyle/>
-                    <a:p>
-                      <a:pPr>
-                        <a:defRPr sz="1200">
-                          <a:solidFill>
-                            <a:srgbClr val="595959"/>
-                          </a:solidFill>
-                        </a:defRPr>
-                      </a:pPr>
-                      <a:r>
-                        <a:t>Benutzeroberfläche</a:t>
-                      </a:r>
-                    </a:p>
-                  </a:txBody>
-                  <a:tcPr anchor="ctr" marL="73152" marR="73152" marT="27432" marB="27432">
-                    <a:solidFill>
-                      <a:srgbClr val="EFEFEF"/>
-                    </a:solidFill>
-                  </a:tcPr>
-                </a:tc>
-                <a:tc>
-                  <a:txBody>
-                    <a:bodyPr/>
-                    <a:lstStyle/>
-                    <a:p>
-                      <a:pPr>
-                        <a:defRPr sz="1200">
-                          <a:solidFill>
-                            <a:srgbClr val="595959"/>
-                          </a:solidFill>
-                        </a:defRPr>
-                      </a:pPr>
-                      <a:r>
-                        <a:t>Open WebUI</a:t>
-                      </a:r>
-                    </a:p>
-                  </a:txBody>
-                  <a:tcPr anchor="ctr" marL="73152" marR="73152" marT="27432" marB="27432">
-                    <a:solidFill>
-                      <a:srgbClr val="EFEFEF"/>
-                    </a:solidFill>
-                  </a:tcPr>
-                </a:tc>
-                <a:tc>
-                  <a:txBody>
-                    <a:bodyPr/>
-                    <a:lstStyle/>
-                    <a:p>
-                      <a:pPr>
-                        <a:defRPr sz="1200">
-                          <a:solidFill>
-                            <a:srgbClr val="595959"/>
-                          </a:solidFill>
-                        </a:defRPr>
-                      </a:pPr>
-                      <a:r>
-                        <a:t>0 € — Open Source</a:t>
-                      </a:r>
-                    </a:p>
-                  </a:txBody>
-                  <a:tcPr anchor="ctr" marL="73152" marR="73152" marT="27432" marB="27432">
-                    <a:solidFill>
-                      <a:srgbClr val="EFEFEF"/>
-                    </a:solidFill>
-                  </a:tcPr>
-                </a:tc>
-              </a:tr>
-              <a:tr h="347472">
-                <a:tc>
-                  <a:txBody>
-                    <a:bodyPr/>
-                    <a:lstStyle/>
-                    <a:p>
-                      <a:pPr>
-                        <a:defRPr sz="1200">
-                          <a:solidFill>
-                            <a:srgbClr val="595959"/>
-                          </a:solidFill>
-                        </a:defRPr>
-                      </a:pPr>
-                      <a:r>
-                        <a:t>Wissensdatenbank</a:t>
-                      </a:r>
-                    </a:p>
-                  </a:txBody>
-                  <a:tcPr anchor="ctr" marL="73152" marR="73152" marT="27432" marB="27432">
-                    <a:solidFill>
-                      <a:srgbClr val="FFFFFF"/>
-                    </a:solidFill>
-                  </a:tcPr>
-                </a:tc>
-                <a:tc>
-                  <a:txBody>
-                    <a:bodyPr/>
-                    <a:lstStyle/>
-                    <a:p>
-                      <a:pPr>
-                        <a:defRPr sz="1200">
-                          <a:solidFill>
-                            <a:srgbClr val="595959"/>
-                          </a:solidFill>
-                        </a:defRPr>
-                      </a:pPr>
-                      <a:r>
-                        <a:t>Qdrant (Vektordatenbank)</a:t>
-                      </a:r>
-                    </a:p>
-                  </a:txBody>
-                  <a:tcPr anchor="ctr" marL="73152" marR="73152" marT="27432" marB="27432">
-                    <a:solidFill>
-                      <a:srgbClr val="FFFFFF"/>
-                    </a:solidFill>
-                  </a:tcPr>
-                </a:tc>
-                <a:tc>
-                  <a:txBody>
-                    <a:bodyPr/>
-                    <a:lstStyle/>
-                    <a:p>
-                      <a:pPr>
-                        <a:defRPr sz="1200">
-                          <a:solidFill>
-                            <a:srgbClr val="595959"/>
-                          </a:solidFill>
-                        </a:defRPr>
-                      </a:pPr>
-                      <a:r>
-                        <a:t>0 € — Open Source</a:t>
-                      </a:r>
-                    </a:p>
-                  </a:txBody>
-                  <a:tcPr anchor="ctr" marL="73152" marR="73152" marT="27432" marB="27432">
-                    <a:solidFill>
-                      <a:srgbClr val="FFFFFF"/>
-                    </a:solidFill>
-                  </a:tcPr>
-                </a:tc>
-              </a:tr>
-              <a:tr h="347472">
-                <a:tc>
-                  <a:txBody>
-                    <a:bodyPr/>
-                    <a:lstStyle/>
-                    <a:p>
-                      <a:pPr>
-                        <a:defRPr sz="1200">
-                          <a:solidFill>
-                            <a:srgbClr val="595959"/>
-                          </a:solidFill>
-                        </a:defRPr>
-                      </a:pPr>
-                      <a:r>
-                        <a:t>Dokumentensuche</a:t>
-                      </a:r>
-                    </a:p>
-                  </a:txBody>
-                  <a:tcPr anchor="ctr" marL="73152" marR="73152" marT="27432" marB="27432">
-                    <a:solidFill>
-                      <a:srgbClr val="EFEFEF"/>
-                    </a:solidFill>
-                  </a:tcPr>
-                </a:tc>
-                <a:tc>
-                  <a:txBody>
-                    <a:bodyPr/>
-                    <a:lstStyle/>
-                    <a:p>
-                      <a:pPr>
-                        <a:defRPr sz="1200">
-                          <a:solidFill>
-                            <a:srgbClr val="595959"/>
-                          </a:solidFill>
-                        </a:defRPr>
-                      </a:pPr>
-                      <a:r>
-                        <a:t>RAG-Verfahren</a:t>
-                      </a:r>
-                    </a:p>
-                  </a:txBody>
-                  <a:tcPr anchor="ctr" marL="73152" marR="73152" marT="27432" marB="27432">
-                    <a:solidFill>
-                      <a:srgbClr val="EFEFEF"/>
-                    </a:solidFill>
-                  </a:tcPr>
-                </a:tc>
-                <a:tc>
-                  <a:txBody>
-                    <a:bodyPr/>
-                    <a:lstStyle/>
-                    <a:p>
-                      <a:pPr>
-                        <a:defRPr sz="1200">
-                          <a:solidFill>
-                            <a:srgbClr val="595959"/>
-                          </a:solidFill>
-                        </a:defRPr>
-                      </a:pPr>
-                      <a:r>
-                        <a:t>0 € — Open Source</a:t>
-                      </a:r>
-                    </a:p>
-                  </a:txBody>
-                  <a:tcPr anchor="ctr" marL="73152" marR="73152" marT="27432" marB="27432">
-                    <a:solidFill>
-                      <a:srgbClr val="EFEFEF"/>
-                    </a:solidFill>
-                  </a:tcPr>
-                </a:tc>
-              </a:tr>
-            </a:tbl>
-          </a:graphicData>
-        </a:graphic>
-      </p:graphicFrame>
+        </p:nvSpPr>
+        <p:spPr>
+          <a:xfrm>
+            <a:off x="502920" y="4069080"/>
+            <a:ext cx="8138160" cy="594360"/>
+          </a:xfrm>
+          <a:prstGeom prst="rect">
+            <a:avLst/>
+          </a:prstGeom>
+          <a:noFill/>
+        </p:spPr>
+        <p:txBody>
+          <a:bodyPr wrap="square">
+            <a:spAutoFit/>
+          </a:bodyPr>
+          <a:lstStyle/>
+          <a:p>
+            <a:pPr algn="ctr"/>
+            <a:r>
+              <a:rPr sz="1400" b="1">
+                <a:solidFill>
+                  <a:srgbClr val="E1001A"/>
+                </a:solidFill>
+              </a:rPr>
+              <a:t>Offener Prüfpunkt für Phase 1: Darf der HessenPC die externe Webadresse erreichen und Dokumente dorthin hochladen?</a:t>
+            </a:r>
+          </a:p>
+        </p:txBody>
+      </p:sp>
     </p:spTree>
   </p:cSld>
   <p:clrMapOvr>
@@ -10180,7 +10020,7 @@
                   <a:srgbClr val="007A33"/>
                 </a:solidFill>
               </a:rPr>
-              <a:t>Phase 1 — sofort startbar</a:t>
+              <a:t>Phase 1 — technisch startbar</a:t>
             </a:r>
           </a:p>
           <a:p>
@@ -10195,7 +10035,7 @@
                   <a:srgbClr val="595959"/>
                 </a:solidFill>
               </a:rPr>
-              <a:t>Abhängig von der HZD:  nein</a:t>
+              <a:t>Live-Anbindung an HZD-Systeme:  nein</a:t>
             </a:r>
           </a:p>
           <a:p>
@@ -10210,7 +10050,7 @@
                   <a:srgbClr val="595959"/>
                 </a:solidFill>
               </a:rPr>
-              <a:t> </a:t>
+              <a:t>HessenPC-Zugriff:  noch zu klären</a:t>
             </a:r>
           </a:p>
           <a:p>
@@ -10225,7 +10065,7 @@
                   <a:srgbClr val="595959"/>
                 </a:solidFill>
               </a:rPr>
-              <a:t>KI-Server läuft außerhalb des Hessennetzes,</a:t>
+              <a:t> </a:t>
             </a:r>
           </a:p>
           <a:p>
@@ -10240,7 +10080,7 @@
                   <a:srgbClr val="595959"/>
                 </a:solidFill>
               </a:rPr>
-              <a:t>in einem EU-Rechenzentrum, DSGVO-konform</a:t>
+              <a:t>KI-Server läuft außerhalb des Hessennetzes,</a:t>
             </a:r>
           </a:p>
           <a:p>
@@ -10255,7 +10095,7 @@
                   <a:srgbClr val="595959"/>
                 </a:solidFill>
               </a:rPr>
-              <a:t> </a:t>
+              <a:t>in einem EU-Rechenzentrum, DSGVO-konform</a:t>
             </a:r>
           </a:p>
           <a:p>
@@ -10270,7 +10110,7 @@
                   <a:srgbClr val="595959"/>
                 </a:solidFill>
               </a:rPr>
-              <a:t>Dokumente werden manuell exportiert und in</a:t>
+              <a:t> </a:t>
             </a:r>
           </a:p>
           <a:p>
@@ -10285,7 +10125,7 @@
                   <a:srgbClr val="595959"/>
                 </a:solidFill>
               </a:rPr>
-              <a:t>die Wissensdatenbank geladen</a:t>
+              <a:t>Dokumente werden manuell exportiert und über</a:t>
             </a:r>
           </a:p>
           <a:p>
@@ -10300,7 +10140,7 @@
                   <a:srgbClr val="595959"/>
                 </a:solidFill>
               </a:rPr>
-              <a:t> </a:t>
+              <a:t>die Weboberfläche in die Wissensbasis geladen</a:t>
             </a:r>
           </a:p>
           <a:p>
@@ -10315,7 +10155,7 @@
                   <a:srgbClr val="595959"/>
                 </a:solidFill>
               </a:rPr>
-              <a:t>Alle Agenten laufen vollständig:</a:t>
+              <a:t> </a:t>
             </a:r>
           </a:p>
           <a:p>
@@ -10330,7 +10170,7 @@
                   <a:srgbClr val="595959"/>
                 </a:solidFill>
               </a:rPr>
-              <a:t>AWA-Assistent, Testfall-Generator,</a:t>
+              <a:t>Alle Agenten laufen vollständig:</a:t>
             </a:r>
           </a:p>
           <a:p>
@@ -10345,7 +10185,7 @@
                   <a:srgbClr val="595959"/>
                 </a:solidFill>
               </a:rPr>
-              <a:t>Wissensassistent</a:t>
+              <a:t>AWA-Assistent, Testfall-Generator,</a:t>
             </a:r>
           </a:p>
           <a:p>
@@ -10360,7 +10200,7 @@
                   <a:srgbClr val="595959"/>
                 </a:solidFill>
               </a:rPr>
-              <a:t> </a:t>
+              <a:t>Wissensassistent</a:t>
             </a:r>
           </a:p>
           <a:p>
@@ -10375,7 +10215,7 @@
                   <a:srgbClr val="595959"/>
                 </a:solidFill>
               </a:rPr>
-              <a:t>Ergebnisse werden manuell in ADO eingetragen</a:t>
+              <a:t> </a:t>
             </a:r>
           </a:p>
           <a:p>
@@ -10390,7 +10230,22 @@
                   <a:srgbClr val="595959"/>
                 </a:solidFill>
               </a:rPr>
-              <a:t>— so wie heute, nur erheblich schneller</a:t>
+              <a:t>Direkte Nutzung am HessenPC nur, wenn die</a:t>
+            </a:r>
+          </a:p>
+          <a:p>
+            <a:pPr>
+              <a:spcBef>
+                <a:spcPts val="400"/>
+              </a:spcBef>
+            </a:pPr>
+            <a:r>
+              <a:rPr sz="1100">
+                <a:solidFill>
+                  <a:srgbClr val="595959"/>
+                </a:solidFill>
+              </a:rPr>
+              <a:t>externe HTTPS-Adresse freigegeben ist</a:t>
             </a:r>
           </a:p>
         </p:txBody>
@@ -10688,7 +10543,7 @@
                   <a:srgbClr val="1F3B63"/>
                 </a:solidFill>
               </a:rPr>
-              <a:t>Phase 1 liefert rund 80 % des Nutzens — und ist vollständig unabhängig lieferbar.</a:t>
+              <a:t>Phase 1 liefert rund 80 % des fachlichen Nutzens — sobald der HessenPC-Zugriff geklärt ist.</a:t>
             </a:r>
           </a:p>
         </p:txBody>

</xml_diff>

<commit_message>
Betriebsmodell der Keller-KI präzisieren
</commit_message>
<xml_diff>
--- a/Anforderungen an eine Corporate LLM/Corporate_LLM_HMKB_Praesentation.pptx
+++ b/Anforderungen an eine Corporate LLM/Corporate_LLM_HMKB_Praesentation.pptx
@@ -807,7 +807,7 @@
           <a:lstStyle/>
           <a:p>
             <a:r>
-              <a:t>Einstieg: Wir sprechen über eine KI, die dem HMKB gehört und im eigenen Haus läuft. Kein Cloud-Dienst, keine Daten bei Dritten. Die zentrale Frage ist nicht 'geht das technisch', sondern 'wie weit kommen wir ohne die HZD'.</a:t>
+              <a:t>Einstieg: Wir sprechen über eine KI, die ausschließlich für das HMKB betrieben wird. Sie nutzt keine externe KI-Schnittstelle; Betriebsort und Netzzugang hängen von der Phase ab. Die zentrale Frage ist nicht 'geht das technisch', sondern 'welcher Zugang ist vom HessenPC realistisch'.</a:t>
             </a:r>
           </a:p>
         </p:txBody>
@@ -7392,7 +7392,7 @@
           <a:lstStyle/>
           <a:p>
             <a:r>
-              <a:t>Corporate LLM im Eigenbetrieb — was mit und was ohne die HZD möglich ist</a:t>
+              <a:t>Corporate LLM unter eigener Kontrolle — was mit und was ohne die HZD möglich ist</a:t>
             </a:r>
           </a:p>
           <a:p>
@@ -7922,7 +7922,7 @@
                   <a:srgbClr val="595959"/>
                 </a:solidFill>
               </a:rPr>
-              <a:t>Ein Corporate LLM — eine Sprach-KI, die dem HMKB gehört und im Eigenbetrieb läuft</a:t>
+              <a:t>Ein Corporate LLM — eine Sprach-KI unter Kontrolle des HMKB</a:t>
             </a:r>
           </a:p>
           <a:p>
@@ -7937,7 +7937,7 @@
                   <a:srgbClr val="595959"/>
                 </a:solidFill>
               </a:rPr>
-              <a:t>Alle Daten bleiben im Haus. Kein Cloud-Anbieter, keine Weitergabe an Dritte</a:t>
+              <a:t>Keine Weitergabe an externe KI-Dienste; Betriebsort und Netzzugang hängen von der Phase ab</a:t>
             </a:r>
           </a:p>
           <a:p>

</xml_diff>

<commit_message>
HessenPC-Zugriff über Internet als Zielweg festhalten
</commit_message>
<xml_diff>
--- a/Anforderungen an eine Corporate LLM/Corporate_LLM_HMKB_Praesentation.pptx
+++ b/Anforderungen an eine Corporate LLM/Corporate_LLM_HMKB_Praesentation.pptx
@@ -877,7 +877,7 @@
           <a:lstStyle/>
           <a:p>
             <a:r>
-              <a:t>Abschluss mit einer konkreten Klärungs- und Entscheidungsfolge. Das Referat soll Phase 2 heute nicht beschließen. Vor einer Entscheidung über Phase 1 muss der Zugriff vom HessenPC auf die externe Webanwendung bestätigt sein.</a:t>
+              <a:t>Abschluss mit einer konkreten Freigabe- und Entscheidungsfolge. Das Referat soll Phase 2 heute nicht beschließen. Für Phase 1 sind Domain, Authentifizierung und Dokumenten-Upload mit der zuständigen IT abzustimmen.</a:t>
             </a:r>
           </a:p>
         </p:txBody>
@@ -1017,7 +1017,7 @@
           <a:lstStyle/>
           <a:p>
             <a:r>
-              <a:t>Wichtig: nicht mit Technik einsteigen. Der Schmerz ist bekannt — händische Testfälle und Doku. Für den Pilot sind zwei Fragen zu trennen: Er braucht keine Live-Anbindung an ADO oder SharePoint. Der Zugriff vom HessenPC auf eine extern betriebene Webanwendung muss aber vorab technisch und organisatorisch bestätigt werden.</a:t>
+              <a:t>Wichtig: nicht mit Technik einsteigen. Der Schmerz ist bekannt — händische Testfälle und Doku. Für den Pilot sind zwei Fragen zu trennen: Er braucht keine Live-Anbindung an ADO oder SharePoint. Der HessenPC erreicht die extern betriebene Webanwendung über die bestehende Internetverbindung. Vorab freizugeben sind die konkrete Domain, die Anmeldung und der Dokumenten-Upload.</a:t>
             </a:r>
           </a:p>
         </p:txBody>
@@ -1367,7 +1367,7 @@
           <a:lstStyle/>
           <a:p>
             <a:r>
-              <a:t>Kernbotschaft der Präsentation. Phase 1 braucht keine Live-Verbindung zu ADO oder SharePoint. Sie ist aber nur am HessenPC nutzbar, wenn die externe, authentifizierte HTTPS-Webadresse erreichbar ist und der Datei-Upload erlaubt wird. Phase 2 bleibt ein Ziel und erfordert die HZD.</a:t>
+              <a:t>Kernbotschaft der Präsentation. Phase 1 braucht keine Live-Verbindung zu ADO oder SharePoint. Der HessenPC erreicht die Weboberfläche über seine bestehende Internetverbindung. Domain, Authentifizierung und Datei-Upload müssen im normalen IT- und Sicherheitsverfahren freigegeben werden. Phase 2 bleibt ein Ziel und erfordert die HZD.</a:t>
             </a:r>
           </a:p>
         </p:txBody>
@@ -7660,7 +7660,7 @@
                   <a:srgbClr val="595959"/>
                 </a:solidFill>
               </a:rPr>
-              <a:t>HessenPC-Zugang kurzfristig mit der zuständigen IT verbindlich klären</a:t>
+              <a:t>Domain, Anmeldung und Dokumenten-Upload mit der zuständigen IT freigeben</a:t>
             </a:r>
           </a:p>
           <a:p>
@@ -7749,7 +7749,7 @@
           </a:p>
           <a:p>
             <a:r>
-              <a:t>Vor dem Start muss nur noch verbindlich geklärt werden, wie der HessenPC die KI-Webanwendung erreicht.</a:t>
+              <a:t>Der Zugriff erfolgt ohne Installation über den Browser am HessenPC; Domain, Anmeldung und Upload werden kontrolliert freigegeben.</a:t>
             </a:r>
           </a:p>
         </p:txBody>
@@ -8004,7 +8004,7 @@
                   <a:srgbClr val="595959"/>
                 </a:solidFill>
               </a:rPr>
-              <a:t>Vorher muss geklärt werden, ob HessenPCs die externe KI-Webadresse erreichen dürfen</a:t>
+              <a:t>HessenPCs erreichen die Weboberfläche über ihre bestehende Internetverbindung</a:t>
             </a:r>
           </a:p>
           <a:p>
@@ -8620,7 +8620,7 @@
                   <a:srgbClr val="E1001A"/>
                 </a:solidFill>
               </a:rPr>
-              <a:t>Offener Prüfpunkt für Phase 1: Darf der HessenPC die externe Webadresse erreichen und Dokumente dorthin hochladen?</a:t>
+              <a:t>Voraussetzung für Phase 1: Domain, Anmeldung und Upload freigegebener Dokumente müssen zugelassen sein.</a:t>
             </a:r>
           </a:p>
         </p:txBody>
@@ -10050,7 +10050,7 @@
                   <a:srgbClr val="595959"/>
                 </a:solidFill>
               </a:rPr>
-              <a:t>HessenPC-Zugriff:  noch zu klären</a:t>
+              <a:t>Zugriff:  HessenPC über das Internet</a:t>
             </a:r>
           </a:p>
           <a:p>
@@ -10230,7 +10230,7 @@
                   <a:srgbClr val="595959"/>
                 </a:solidFill>
               </a:rPr>
-              <a:t>Direkte Nutzung am HessenPC nur, wenn die</a:t>
+              <a:t>Standardfreigaben bleiben erforderlich:</a:t>
             </a:r>
           </a:p>
           <a:p>
@@ -10245,7 +10245,7 @@
                   <a:srgbClr val="595959"/>
                 </a:solidFill>
               </a:rPr>
-              <a:t>externe HTTPS-Adresse freigegeben ist</a:t>
+              <a:t>Domain, Anmeldung und Dokumenten-Upload</a:t>
             </a:r>
           </a:p>
         </p:txBody>
@@ -10543,7 +10543,7 @@
                   <a:srgbClr val="1F3B63"/>
                 </a:solidFill>
               </a:rPr>
-              <a:t>Phase 1 liefert rund 80 % des fachlichen Nutzens — sobald der HessenPC-Zugriff geklärt ist.</a:t>
+              <a:t>Phase 1 liefert rund 80 % des fachlichen Nutzens — erreichbar über den Browser am HessenPC.</a:t>
             </a:r>
           </a:p>
         </p:txBody>

</xml_diff>